<commit_message>
Regenerate USER_GUIDE.docx and PPTX decks from refreshed screenshots
- USER_GUIDE.docx rebuilt via mdconverter (pandoc) from the updated
  USER_GUIDE.md, with all 12 embedded screenshots.
- 23_code_slips.png and 24_paper_ballot.png re-captured against a fresh
  demo election (the images used by create_pptx.js).
- FRCA_Election_App_Training.pptx and FRCA_Election_App_Proposal.pptx
  rebuilt from the current screenshots/ contents.
</commit_message>
<xml_diff>
--- a/voting-app/docs/FRCA_Election_App_Training.pptx
+++ b/voting-app/docs/FRCA_Election_App_Training.pptx
@@ -5308,40 +5308,6 @@
             </a:r>
             <a:endParaRPr lang="en-US" sz="1400" dirty="0"/>
           </a:p>
-          <a:p>
-            <a:pPr indent="0" marL="0">
-              <a:buNone/>
-            </a:pPr>
-            <a:r>
-              <a:rPr lang="en-US" sz="1300" i="1" dirty="0">
-                <a:solidFill>
-                  <a:srgbClr val="5D6D7E"/>
-                </a:solidFill>
-                <a:latin typeface="Calibri" pitchFamily="34" charset="0"/>
-                <a:ea typeface="Calibri" pitchFamily="34" charset="-122"/>
-                <a:cs typeface="Calibri" pitchFamily="34" charset="-120"/>
-              </a:rPr>
-              <a:t>You can mark it as an interim election</a:t>
-            </a:r>
-            <a:endParaRPr lang="en-US" sz="1400" dirty="0"/>
-          </a:p>
-          <a:p>
-            <a:pPr indent="0" marL="0">
-              <a:buNone/>
-            </a:pPr>
-            <a:r>
-              <a:rPr lang="en-US" sz="1300" i="1" dirty="0">
-                <a:solidFill>
-                  <a:srgbClr val="5D6D7E"/>
-                </a:solidFill>
-                <a:latin typeface="Calibri" pitchFamily="34" charset="0"/>
-                <a:ea typeface="Calibri" pitchFamily="34" charset="-122"/>
-                <a:cs typeface="Calibri" pitchFamily="34" charset="-120"/>
-              </a:rPr>
-              <a:t>(Article 11) if applicable.</a:t>
-            </a:r>
-            <a:endParaRPr lang="en-US" sz="1400" dirty="0"/>
-          </a:p>
         </p:txBody>
       </p:sp>
     </p:spTree>

</xml_diff>